<commit_message>
Waqf: stop signs drawn above the last letter of the word (Quranic high marks), not beside it
Co-Authored-By: Claude Opus 5.5 <noreply@anthropic.com>
Claude-Session: https://claude.ai/code/session_01XjTEwQ8YdBa1SjcPiYTm9z
</commit_message>
<xml_diff>
--- a/waqf/Stopping-Waqf.pptx
+++ b/waqf/Stopping-Waqf.pptx
@@ -5355,7 +5355,7 @@
         </p:nvSpPr>
         <p:spPr>
           <a:xfrm>
-            <a:off x="365760" y="1569966"/>
+            <a:off x="365760" y="1590675"/>
             <a:ext cx="8412480" cy="1417320"/>
           </a:xfrm>
           <a:prstGeom prst="rect">
@@ -5372,7 +5372,7 @@
               <a:buNone/>
             </a:pPr>
             <a:r>
-              <a:rPr lang="ar-SA" altLang="en-US" sz="4100" dirty="0">
+              <a:rPr lang="ar-SA" altLang="en-US" sz="3900" dirty="0">
                 <a:solidFill>
                   <a:srgbClr val="16213E"/>
                 </a:solidFill>
@@ -5380,13 +5380,13 @@
                 <a:ea typeface="Traditional Arabic" pitchFamily="34" charset="-122"/>
                 <a:cs typeface="Traditional Arabic" pitchFamily="34" charset="-120"/>
               </a:rPr>
-              <a:t>وَلَمۡ يَجۡعَل لَّهُۥ عِوَجَا </a:t>
+              <a:t>وَلَمۡ يَجۡعَل لَّهُۥ عِوَجَا</a:t>
             </a:r>
             <a:pPr algn="ctr" indent="0" marL="0">
               <a:buNone/>
             </a:pPr>
             <a:r>
-              <a:rPr lang="ar-SA" altLang="en-US" sz="2300" b="1" dirty="0">
+              <a:rPr lang="ar-SA" altLang="en-US" sz="3900" dirty="0">
                 <a:solidFill>
                   <a:srgbClr val="E03131"/>
                 </a:solidFill>
@@ -5394,13 +5394,13 @@
                 <a:ea typeface="Traditional Arabic" pitchFamily="34" charset="-122"/>
                 <a:cs typeface="Traditional Arabic" pitchFamily="34" charset="-120"/>
               </a:rPr>
-              <a:t> س </a:t>
+              <a:t>ۜ</a:t>
             </a:r>
             <a:pPr algn="ctr" indent="0" marL="0">
               <a:buNone/>
             </a:pPr>
             <a:r>
-              <a:rPr lang="ar-SA" altLang="en-US" sz="4100" dirty="0">
+              <a:rPr lang="ar-SA" altLang="en-US" sz="3900" dirty="0">
                 <a:solidFill>
                   <a:srgbClr val="16213E"/>
                 </a:solidFill>
@@ -5410,7 +5410,7 @@
               </a:rPr>
               <a:t> قَيِّمًا</a:t>
             </a:r>
-            <a:endParaRPr lang="ar-SA" sz="4100" dirty="0"/>
+            <a:endParaRPr lang="ar-SA" sz="3900" dirty="0"/>
           </a:p>
         </p:txBody>
       </p:sp>
@@ -15960,7 +15960,7 @@
         </p:nvSpPr>
         <p:spPr>
           <a:xfrm>
-            <a:off x="502920" y="3702304"/>
+            <a:off x="502920" y="3706368"/>
             <a:ext cx="8138160" cy="512064"/>
           </a:xfrm>
           <a:prstGeom prst="rect">
@@ -15977,7 +15977,7 @@
               <a:buNone/>
             </a:pPr>
             <a:r>
-              <a:rPr lang="en-US" sz="1900" dirty="0">
+              <a:rPr lang="en-US" sz="1500" dirty="0">
                 <a:solidFill>
                   <a:srgbClr val="16213E"/>
                 </a:solidFill>
@@ -15985,9 +15985,9 @@
                 <a:ea typeface="Arial" pitchFamily="34" charset="-122"/>
                 <a:cs typeface="Arial" pitchFamily="34" charset="-120"/>
               </a:rPr>
-              <a:t>The signs are small letters printed above the end of a word.</a:t>
+              <a:t>In the Mushaf these signs are printed small, ABOVE the last letter of the word.</a:t>
             </a:r>
-            <a:endParaRPr lang="en-US" sz="1900" dirty="0"/>
+            <a:endParaRPr lang="en-US" sz="1500" dirty="0"/>
           </a:p>
         </p:txBody>
       </p:sp>
@@ -27230,7 +27230,7 @@
         </p:nvSpPr>
         <p:spPr>
           <a:xfrm>
-            <a:off x="365760" y="1554646"/>
+            <a:off x="365760" y="1559922"/>
             <a:ext cx="8412480" cy="1417320"/>
           </a:xfrm>
           <a:prstGeom prst="rect">
@@ -27247,7 +27247,7 @@
               <a:buNone/>
             </a:pPr>
             <a:r>
-              <a:rPr lang="ar-SA" altLang="en-US" sz="3600" dirty="0">
+              <a:rPr lang="ar-SA" altLang="en-US" sz="3700" dirty="0">
                 <a:solidFill>
                   <a:srgbClr val="16213E"/>
                 </a:solidFill>
@@ -27255,13 +27255,13 @@
                 <a:ea typeface="Traditional Arabic" pitchFamily="34" charset="-122"/>
                 <a:cs typeface="Traditional Arabic" pitchFamily="34" charset="-120"/>
               </a:rPr>
-              <a:t>وَلَا يَحۡزُنكَ قَوۡلُهُمۡ </a:t>
+              <a:t>وَلَا يَحۡزُنكَ قَوۡلُهُمۡ</a:t>
             </a:r>
             <a:pPr algn="ctr" indent="0" marL="0">
               <a:buNone/>
             </a:pPr>
             <a:r>
-              <a:rPr lang="ar-SA" altLang="en-US" sz="2000" b="1" dirty="0">
+              <a:rPr lang="ar-SA" altLang="en-US" sz="3700" dirty="0">
                 <a:solidFill>
                   <a:srgbClr val="E03131"/>
                 </a:solidFill>
@@ -27269,13 +27269,13 @@
                 <a:ea typeface="Traditional Arabic" pitchFamily="34" charset="-122"/>
                 <a:cs typeface="Traditional Arabic" pitchFamily="34" charset="-120"/>
               </a:rPr>
-              <a:t> مـ </a:t>
+              <a:t>ۘ</a:t>
             </a:r>
             <a:pPr algn="ctr" indent="0" marL="0">
               <a:buNone/>
             </a:pPr>
             <a:r>
-              <a:rPr lang="ar-SA" altLang="en-US" sz="3600" dirty="0">
+              <a:rPr lang="ar-SA" altLang="en-US" sz="3700" dirty="0">
                 <a:solidFill>
                   <a:srgbClr val="16213E"/>
                 </a:solidFill>
@@ -27285,7 +27285,7 @@
               </a:rPr>
               <a:t> إِنَّ ٱلۡعِزَّةَ لِلَّهِ جَمِيعًا</a:t>
             </a:r>
-            <a:endParaRPr lang="ar-SA" sz="3600" dirty="0"/>
+            <a:endParaRPr lang="ar-SA" sz="3700" dirty="0"/>
           </a:p>
         </p:txBody>
       </p:sp>
@@ -35541,7 +35541,7 @@
         </p:nvSpPr>
         <p:spPr>
           <a:xfrm>
-            <a:off x="365760" y="1591621"/>
+            <a:off x="365760" y="1593533"/>
             <a:ext cx="8412480" cy="1417320"/>
           </a:xfrm>
           <a:prstGeom prst="rect">
@@ -35558,7 +35558,7 @@
               <a:buNone/>
             </a:pPr>
             <a:r>
-              <a:rPr lang="ar-SA" altLang="en-US" sz="2900" dirty="0">
+              <a:rPr lang="ar-SA" altLang="en-US" sz="3000" dirty="0">
                 <a:solidFill>
                   <a:srgbClr val="16213E"/>
                 </a:solidFill>
@@ -35566,13 +35566,13 @@
                 <a:ea typeface="Traditional Arabic" pitchFamily="34" charset="-122"/>
                 <a:cs typeface="Traditional Arabic" pitchFamily="34" charset="-120"/>
               </a:rPr>
-              <a:t>ٱلَّذِينَ تَتَوَفَّىٰهُمُ ٱلۡمَلَٰٓئِكَةُ طَيِّبِينَ </a:t>
+              <a:t>ٱلَّذِينَ تَتَوَفَّىٰهُمُ ٱلۡمَلَٰٓئِكَةُ طَيِّبِينَ</a:t>
             </a:r>
             <a:pPr algn="ctr" indent="0" marL="0">
               <a:buNone/>
             </a:pPr>
             <a:r>
-              <a:rPr lang="ar-SA" altLang="en-US" sz="1600" b="1" dirty="0">
+              <a:rPr lang="ar-SA" altLang="en-US" sz="3000" dirty="0">
                 <a:solidFill>
                   <a:srgbClr val="E03131"/>
                 </a:solidFill>
@@ -35580,13 +35580,13 @@
                 <a:ea typeface="Traditional Arabic" pitchFamily="34" charset="-122"/>
                 <a:cs typeface="Traditional Arabic" pitchFamily="34" charset="-120"/>
               </a:rPr>
-              <a:t> لا </a:t>
+              <a:t>ۙ</a:t>
             </a:r>
             <a:pPr algn="ctr" indent="0" marL="0">
               <a:buNone/>
             </a:pPr>
             <a:r>
-              <a:rPr lang="ar-SA" altLang="en-US" sz="2900" dirty="0">
+              <a:rPr lang="ar-SA" altLang="en-US" sz="3000" dirty="0">
                 <a:solidFill>
                   <a:srgbClr val="16213E"/>
                 </a:solidFill>
@@ -35596,7 +35596,7 @@
               </a:rPr>
               <a:t> يَقُولُونَ سَلَٰمٌ عَلَيۡكُمُ</a:t>
             </a:r>
-            <a:endParaRPr lang="ar-SA" sz="2900" dirty="0"/>
+            <a:endParaRPr lang="ar-SA" sz="3000" dirty="0"/>
           </a:p>
         </p:txBody>
       </p:sp>
@@ -36349,7 +36349,7 @@
         </p:nvSpPr>
         <p:spPr>
           <a:xfrm>
-            <a:off x="365760" y="1543702"/>
+            <a:off x="365760" y="1569872"/>
             <a:ext cx="8412480" cy="1417320"/>
           </a:xfrm>
           <a:prstGeom prst="rect">
@@ -36374,13 +36374,13 @@
                 <a:ea typeface="Traditional Arabic" pitchFamily="34" charset="-122"/>
                 <a:cs typeface="Traditional Arabic" pitchFamily="34" charset="-120"/>
               </a:rPr>
-              <a:t>نَّحۡنُ نَقُصُّ عَلَيۡكَ نَبَأَهُم بِٱلۡحَقِّ </a:t>
+              <a:t>نَّحۡنُ نَقُصُّ عَلَيۡكَ نَبَأَهُم بِٱلۡحَقِّ</a:t>
             </a:r>
             <a:pPr algn="ctr" indent="0" marL="0">
               <a:buNone/>
             </a:pPr>
             <a:r>
-              <a:rPr lang="ar-SA" altLang="en-US" sz="1300" b="1" dirty="0">
+              <a:rPr lang="ar-SA" altLang="en-US" sz="2400" dirty="0">
                 <a:solidFill>
                   <a:srgbClr val="E03131"/>
                 </a:solidFill>
@@ -36388,7 +36388,7 @@
                 <a:ea typeface="Traditional Arabic" pitchFamily="34" charset="-122"/>
                 <a:cs typeface="Traditional Arabic" pitchFamily="34" charset="-120"/>
               </a:rPr>
-              <a:t> ج </a:t>
+              <a:t>ۚ</a:t>
             </a:r>
             <a:pPr algn="ctr" indent="0" marL="0">
               <a:buNone/>
@@ -37347,7 +37347,7 @@
         </p:nvSpPr>
         <p:spPr>
           <a:xfrm>
-            <a:off x="365760" y="1542634"/>
+            <a:off x="365760" y="1569225"/>
             <a:ext cx="8412480" cy="1417320"/>
           </a:xfrm>
           <a:prstGeom prst="rect">
@@ -37364,7 +37364,7 @@
               <a:buNone/>
             </a:pPr>
             <a:r>
-              <a:rPr lang="ar-SA" altLang="en-US" sz="3100" dirty="0">
+              <a:rPr lang="ar-SA" altLang="en-US" sz="3400" dirty="0">
                 <a:solidFill>
                   <a:srgbClr val="16213E"/>
                 </a:solidFill>
@@ -37372,13 +37372,13 @@
                 <a:ea typeface="Traditional Arabic" pitchFamily="34" charset="-122"/>
                 <a:cs typeface="Traditional Arabic" pitchFamily="34" charset="-120"/>
               </a:rPr>
-              <a:t>فَلَا كَاشِفَ لَهُۥٓ إِلَّا هُوَ </a:t>
+              <a:t>فَلَا كَاشِفَ لَهُۥٓ إِلَّا هُوَ</a:t>
             </a:r>
             <a:pPr algn="ctr" indent="0" marL="0">
               <a:buNone/>
             </a:pPr>
             <a:r>
-              <a:rPr lang="ar-SA" altLang="en-US" sz="1700" b="1" dirty="0">
+              <a:rPr lang="ar-SA" altLang="en-US" sz="3400" dirty="0">
                 <a:solidFill>
                   <a:srgbClr val="E03131"/>
                 </a:solidFill>
@@ -37386,13 +37386,13 @@
                 <a:ea typeface="Traditional Arabic" pitchFamily="34" charset="-122"/>
                 <a:cs typeface="Traditional Arabic" pitchFamily="34" charset="-120"/>
               </a:rPr>
-              <a:t> صلى </a:t>
+              <a:t>ۖ</a:t>
             </a:r>
             <a:pPr algn="ctr" indent="0" marL="0">
               <a:buNone/>
             </a:pPr>
             <a:r>
-              <a:rPr lang="ar-SA" altLang="en-US" sz="3100" dirty="0">
+              <a:rPr lang="ar-SA" altLang="en-US" sz="3400" dirty="0">
                 <a:solidFill>
                   <a:srgbClr val="16213E"/>
                 </a:solidFill>
@@ -37402,7 +37402,7 @@
               </a:rPr>
               <a:t> وَإِن يَمۡسَسۡكَ بِخَيۡرٍ</a:t>
             </a:r>
-            <a:endParaRPr lang="ar-SA" sz="3100" dirty="0"/>
+            <a:endParaRPr lang="ar-SA" sz="3400" dirty="0"/>
           </a:p>
         </p:txBody>
       </p:sp>
@@ -38272,7 +38272,7 @@
         </p:nvSpPr>
         <p:spPr>
           <a:xfrm>
-            <a:off x="365760" y="1555159"/>
+            <a:off x="365760" y="1590465"/>
             <a:ext cx="8412480" cy="1417320"/>
           </a:xfrm>
           <a:prstGeom prst="rect">
@@ -38297,13 +38297,13 @@
                 <a:ea typeface="Traditional Arabic" pitchFamily="34" charset="-122"/>
                 <a:cs typeface="Traditional Arabic" pitchFamily="34" charset="-120"/>
               </a:rPr>
-              <a:t>مَّا يَعۡلَمُهُمۡ إِلَّا قَلِيلٌ </a:t>
+              <a:t>مَّا يَعۡلَمُهُمۡ إِلَّا قَلِيلٌ</a:t>
             </a:r>
             <a:pPr algn="ctr" indent="0" marL="0">
               <a:buNone/>
             </a:pPr>
             <a:r>
-              <a:rPr lang="ar-SA" altLang="en-US" sz="2000" b="1" dirty="0">
+              <a:rPr lang="ar-SA" altLang="en-US" sz="3700" dirty="0">
                 <a:solidFill>
                   <a:srgbClr val="E03131"/>
                 </a:solidFill>
@@ -38311,7 +38311,7 @@
                 <a:ea typeface="Traditional Arabic" pitchFamily="34" charset="-122"/>
                 <a:cs typeface="Traditional Arabic" pitchFamily="34" charset="-120"/>
               </a:rPr>
-              <a:t> قلى </a:t>
+              <a:t>ۗ</a:t>
             </a:r>
             <a:pPr algn="ctr" indent="0" marL="0">
               <a:buNone/>
@@ -39070,7 +39070,7 @@
         </p:nvSpPr>
         <p:spPr>
           <a:xfrm>
-            <a:off x="365760" y="1602423"/>
+            <a:off x="365760" y="1611376"/>
             <a:ext cx="8412480" cy="1417320"/>
           </a:xfrm>
           <a:prstGeom prst="rect">
@@ -39087,7 +39087,7 @@
               <a:buNone/>
             </a:pPr>
             <a:r>
-              <a:rPr lang="ar-SA" altLang="en-US" sz="3600" dirty="0">
+              <a:rPr lang="ar-SA" altLang="en-US" sz="3700" dirty="0">
                 <a:solidFill>
                   <a:srgbClr val="16213E"/>
                 </a:solidFill>
@@ -39095,13 +39095,13 @@
                 <a:ea typeface="Traditional Arabic" pitchFamily="34" charset="-122"/>
                 <a:cs typeface="Traditional Arabic" pitchFamily="34" charset="-120"/>
               </a:rPr>
-              <a:t>ذَٰلِكَ ٱلۡكِتَٰبُ لَا رَيۡبَ </a:t>
+              <a:t>ذَٰلِكَ ٱلۡكِتَٰبُ لَا رَيۡبَ</a:t>
             </a:r>
             <a:pPr algn="ctr" indent="0" marL="0">
               <a:buNone/>
             </a:pPr>
             <a:r>
-              <a:rPr lang="ar-SA" altLang="en-US" sz="2000" b="1" dirty="0">
+              <a:rPr lang="ar-SA" altLang="en-US" sz="3700" dirty="0">
                 <a:solidFill>
                   <a:srgbClr val="E03131"/>
                 </a:solidFill>
@@ -39109,13 +39109,13 @@
                 <a:ea typeface="Traditional Arabic" pitchFamily="34" charset="-122"/>
                 <a:cs typeface="Traditional Arabic" pitchFamily="34" charset="-120"/>
               </a:rPr>
-              <a:t> ∴ </a:t>
+              <a:t>ۛ</a:t>
             </a:r>
             <a:pPr algn="ctr" indent="0" marL="0">
               <a:buNone/>
             </a:pPr>
             <a:r>
-              <a:rPr lang="ar-SA" altLang="en-US" sz="3600" dirty="0">
+              <a:rPr lang="ar-SA" altLang="en-US" sz="3700" dirty="0">
                 <a:solidFill>
                   <a:srgbClr val="16213E"/>
                 </a:solidFill>
@@ -39123,13 +39123,13 @@
                 <a:ea typeface="Traditional Arabic" pitchFamily="34" charset="-122"/>
                 <a:cs typeface="Traditional Arabic" pitchFamily="34" charset="-120"/>
               </a:rPr>
-              <a:t> فِيهِ </a:t>
+              <a:t> فِيهِ</a:t>
             </a:r>
             <a:pPr algn="ctr" indent="0" marL="0">
               <a:buNone/>
             </a:pPr>
             <a:r>
-              <a:rPr lang="ar-SA" altLang="en-US" sz="2000" b="1" dirty="0">
+              <a:rPr lang="ar-SA" altLang="en-US" sz="3700" dirty="0">
                 <a:solidFill>
                   <a:srgbClr val="E03131"/>
                 </a:solidFill>
@@ -39137,13 +39137,13 @@
                 <a:ea typeface="Traditional Arabic" pitchFamily="34" charset="-122"/>
                 <a:cs typeface="Traditional Arabic" pitchFamily="34" charset="-120"/>
               </a:rPr>
-              <a:t> ∴ </a:t>
+              <a:t>ۛ</a:t>
             </a:r>
             <a:pPr algn="ctr" indent="0" marL="0">
               <a:buNone/>
             </a:pPr>
             <a:r>
-              <a:rPr lang="ar-SA" altLang="en-US" sz="3600" dirty="0">
+              <a:rPr lang="ar-SA" altLang="en-US" sz="3700" dirty="0">
                 <a:solidFill>
                   <a:srgbClr val="16213E"/>
                 </a:solidFill>
@@ -39153,7 +39153,7 @@
               </a:rPr>
               <a:t> هُدًى لِّلۡمُتَّقِينَ</a:t>
             </a:r>
-            <a:endParaRPr lang="ar-SA" sz="3600" dirty="0"/>
+            <a:endParaRPr lang="ar-SA" sz="3700" dirty="0"/>
           </a:p>
         </p:txBody>
       </p:sp>
@@ -39921,7 +39921,7 @@
         </p:nvSpPr>
         <p:spPr>
           <a:xfrm>
-            <a:off x="365760" y="1555853"/>
+            <a:off x="365760" y="1554010"/>
             <a:ext cx="8412480" cy="1417320"/>
           </a:xfrm>
           <a:prstGeom prst="rect">
@@ -39938,7 +39938,7 @@
               <a:buNone/>
             </a:pPr>
             <a:r>
-              <a:rPr lang="ar-SA" altLang="en-US" sz="3200" dirty="0">
+              <a:rPr lang="ar-SA" altLang="en-US" sz="2900" dirty="0">
                 <a:solidFill>
                   <a:srgbClr val="16213E"/>
                 </a:solidFill>
@@ -39952,7 +39952,7 @@
               <a:buNone/>
             </a:pPr>
             <a:r>
-              <a:rPr lang="ar-SA" altLang="en-US" sz="1800" b="1" dirty="0">
+              <a:rPr lang="ar-SA" altLang="en-US" sz="2900" dirty="0">
                 <a:solidFill>
                   <a:srgbClr val="E03131"/>
                 </a:solidFill>
@@ -39960,13 +39960,13 @@
                 <a:ea typeface="Traditional Arabic" pitchFamily="34" charset="-122"/>
                 <a:cs typeface="Traditional Arabic" pitchFamily="34" charset="-120"/>
               </a:rPr>
-              <a:t> 1 </a:t>
+              <a:t>﴿٢﴾</a:t>
             </a:r>
             <a:pPr algn="ctr" indent="0" marL="0">
               <a:buNone/>
             </a:pPr>
             <a:r>
-              <a:rPr lang="ar-SA" altLang="en-US" sz="3200" dirty="0">
+              <a:rPr lang="ar-SA" altLang="en-US" sz="2900" dirty="0">
                 <a:solidFill>
                   <a:srgbClr val="16213E"/>
                 </a:solidFill>
@@ -39980,7 +39980,7 @@
               <a:buNone/>
             </a:pPr>
             <a:r>
-              <a:rPr lang="ar-SA" altLang="en-US" sz="1800" b="1" dirty="0">
+              <a:rPr lang="ar-SA" altLang="en-US" sz="2900" dirty="0">
                 <a:solidFill>
                   <a:srgbClr val="E03131"/>
                 </a:solidFill>
@@ -39988,9 +39988,9 @@
                 <a:ea typeface="Traditional Arabic" pitchFamily="34" charset="-122"/>
                 <a:cs typeface="Traditional Arabic" pitchFamily="34" charset="-120"/>
               </a:rPr>
-              <a:t> 2 </a:t>
+              <a:t>﴿٣﴾</a:t>
             </a:r>
-            <a:endParaRPr lang="ar-SA" sz="3200" dirty="0"/>
+            <a:endParaRPr lang="ar-SA" sz="2900" dirty="0"/>
           </a:p>
         </p:txBody>
       </p:sp>

</xml_diff>